<commit_message>
docs: update evidence slide with live 2-of-10 clarification result
</commit_message>
<xml_diff>
--- a/demo-slides.pptx
+++ b/demo-slides.pptx
@@ -4024,7 +4024,7 @@
               </a:defRPr>
             </a:pPr>
             <a:r>
-              <a:t>0,19%</a:t>
+              <a:t>2/10</a:t>
             </a:r>
           </a:p>
         </p:txBody>
@@ -4060,7 +4060,7 @@
               </a:defRPr>
             </a:pPr>
             <a:r>
-              <a:t>tỷ lệ hỏi lại</a:t>
+              <a:t>case live hỏi lại đúng</a:t>
             </a:r>
           </a:p>
         </p:txBody>
@@ -4141,7 +4141,7 @@
               </a:defRPr>
             </a:pPr>
             <a:r>
-              <a:t>4/4</a:t>
+              <a:t>8/10</a:t>
             </a:r>
           </a:p>
         </p:txBody>
@@ -4271,8 +4271,8 @@
         </p:nvSpPr>
         <p:spPr>
           <a:xfrm>
-            <a:off x="868680" y="4005072"/>
-            <a:ext cx="10424160" cy="777240"/>
+            <a:off x="868680" y="3931920"/>
+            <a:ext cx="10424160" cy="914400"/>
           </a:xfrm>
           <a:prstGeom prst="rect">
             <a:avLst/>
@@ -4286,7 +4286,7 @@
           <a:lstStyle/>
           <a:p>
             <a:pPr algn="l">
-              <a:defRPr sz="1800" b="0">
+              <a:defRPr sz="1600" b="0">
                 <a:solidFill>
                   <a:srgbClr val="141E30"/>
                 </a:solidFill>
@@ -4294,7 +4294,7 @@
               </a:defRPr>
             </a:pPr>
             <a:r>
-              <a:t>Trên trang lớp 3B, câu “cho tôi link” được Tutor hiểu theo một giả định và trả link repo lớp 3A. Học viên phải tự phát hiện và hỏi lại.</a:t>
+              <a:t>Fail: “cho tôi link” · “form đâu” · “repo nào” · “đáp án gì” · “cái này là gì” · “giải thích đoạn trên” · “cgi” · “giúp tôi với”. Riêng “cho tôi link” trả nhầm repo lớp 3A trên trang 3B.</a:t>
             </a:r>
           </a:p>
         </p:txBody>

</xml_diff>

<commit_message>
feat: refresh CP5 deck and public demo prompt
</commit_message>
<xml_diff>
--- a/demo-slides.pptx
+++ b/demo-slides.pptx
@@ -4024,7 +4024,7 @@
               </a:defRPr>
             </a:pPr>
             <a:r>
-              <a:t>2/10</a:t>
+              <a:t>2/11</a:t>
             </a:r>
           </a:p>
         </p:txBody>
@@ -4141,7 +4141,7 @@
               </a:defRPr>
             </a:pPr>
             <a:r>
-              <a:t>8/10</a:t>
+              <a:t>9/11</a:t>
             </a:r>
           </a:p>
         </p:txBody>
@@ -4330,7 +4330,7 @@
               </a:defRPr>
             </a:pPr>
             <a:r>
-              <a:t>Nguồn: tutor_turns.csv + kiểm thử VLearn 17/09 · phương pháp tái lập nằm trong evidence/</a:t>
+              <a:t>Nguồn: tutor_turns.csv + kiểm thử VLearn 17–18/09 · phương pháp tái lập nằm trong evidence/</a:t>
             </a:r>
           </a:p>
         </p:txBody>
@@ -7427,8 +7427,8 @@
         </p:nvSpPr>
         <p:spPr>
           <a:xfrm>
-            <a:off x="640080" y="5074920"/>
-            <a:ext cx="10972800" cy="594360"/>
+            <a:off x="640080" y="4983480"/>
+            <a:ext cx="10972800" cy="502920"/>
           </a:xfrm>
           <a:prstGeom prst="rect">
             <a:avLst/>
@@ -7442,7 +7442,7 @@
           <a:lstStyle/>
           <a:p>
             <a:pPr algn="l">
-              <a:defRPr sz="1800" b="1">
+              <a:defRPr sz="1700" b="1">
                 <a:solidFill>
                   <a:srgbClr val="141E30"/>
                 </a:solidFill>
@@ -7450,7 +7450,43 @@
               </a:defRPr>
             </a:pPr>
             <a:r>
-              <a:t>Tiếp theo: cho 3 willing users dùng thử, ghi quote nguyên văn và chỉ sửa theo điểm kẹt quan sát được.</a:t>
+              <a:t>Tiếp theo: cho 5 willing users dùng thử, ghi quote nguyên văn và chỉ sửa theo điểm kẹt quan sát được.</a:t>
+            </a:r>
+          </a:p>
+        </p:txBody>
+      </p:sp>
+      <p:sp>
+        <p:nvSpPr>
+          <p:cNvPr id="20" name="TextBox 19"/>
+          <p:cNvSpPr txBox="1"/>
+          <p:nvPr/>
+        </p:nvSpPr>
+        <p:spPr>
+          <a:xfrm>
+            <a:off x="640080" y="5596128"/>
+            <a:ext cx="10972800" cy="274320"/>
+          </a:xfrm>
+          <a:prstGeom prst="rect">
+            <a:avLst/>
+          </a:prstGeom>
+          <a:noFill/>
+        </p:spPr>
+        <p:txBody>
+          <a:bodyPr wrap="square">
+            <a:spAutoFit/>
+          </a:bodyPr>
+          <a:lstStyle/>
+          <a:p>
+            <a:pPr algn="ctr">
+              <a:defRPr sz="1200" b="0">
+                <a:solidFill>
+                  <a:srgbClr val="5C6B7E"/>
+                </a:solidFill>
+                <a:latin typeface="Aptos"/>
+              </a:defRPr>
+            </a:pPr>
+            <a:r>
+              <a:t>Prototype public: vlearn-clarify-first-kingpro.vercel.app</a:t>
             </a:r>
           </a:p>
         </p:txBody>

</xml_diff>